<commit_message>
[2026.07.20.월] : 아이템 추가
</commit_message>
<xml_diff>
--- a/assets/편집.pptx
+++ b/assets/편집.pptx
@@ -198,7 +198,7 @@
           <a:p>
             <a:fld id="{735E9D12-1D51-4C5A-9100-BEF5B44C6E9F}" type="datetimeFigureOut">
               <a:rPr lang="ko-KR" altLang="en-US" smtClean="0"/>
-              <a:t>2026-03-07-Sat</a:t>
+              <a:t>2026-07-20-Mon</a:t>
             </a:fld>
             <a:endParaRPr lang="ko-KR" altLang="en-US"/>
           </a:p>
@@ -696,7 +696,7 @@
           <a:p>
             <a:fld id="{D9F17D16-5A3B-479C-971A-D492ADD6ED98}" type="datetimeFigureOut">
               <a:rPr lang="ko-KR" altLang="en-US" smtClean="0"/>
-              <a:t>2026-03-07-Sat</a:t>
+              <a:t>2026-07-20-Mon</a:t>
             </a:fld>
             <a:endParaRPr lang="ko-KR" altLang="en-US"/>
           </a:p>
@@ -894,7 +894,7 @@
           <a:p>
             <a:fld id="{D9F17D16-5A3B-479C-971A-D492ADD6ED98}" type="datetimeFigureOut">
               <a:rPr lang="ko-KR" altLang="en-US" smtClean="0"/>
-              <a:t>2026-03-07-Sat</a:t>
+              <a:t>2026-07-20-Mon</a:t>
             </a:fld>
             <a:endParaRPr lang="ko-KR" altLang="en-US"/>
           </a:p>
@@ -1102,7 +1102,7 @@
           <a:p>
             <a:fld id="{D9F17D16-5A3B-479C-971A-D492ADD6ED98}" type="datetimeFigureOut">
               <a:rPr lang="ko-KR" altLang="en-US" smtClean="0"/>
-              <a:t>2026-03-07-Sat</a:t>
+              <a:t>2026-07-20-Mon</a:t>
             </a:fld>
             <a:endParaRPr lang="ko-KR" altLang="en-US"/>
           </a:p>
@@ -1300,7 +1300,7 @@
           <a:p>
             <a:fld id="{D9F17D16-5A3B-479C-971A-D492ADD6ED98}" type="datetimeFigureOut">
               <a:rPr lang="ko-KR" altLang="en-US" smtClean="0"/>
-              <a:t>2026-03-07-Sat</a:t>
+              <a:t>2026-07-20-Mon</a:t>
             </a:fld>
             <a:endParaRPr lang="ko-KR" altLang="en-US"/>
           </a:p>
@@ -1575,7 +1575,7 @@
           <a:p>
             <a:fld id="{D9F17D16-5A3B-479C-971A-D492ADD6ED98}" type="datetimeFigureOut">
               <a:rPr lang="ko-KR" altLang="en-US" smtClean="0"/>
-              <a:t>2026-03-07-Sat</a:t>
+              <a:t>2026-07-20-Mon</a:t>
             </a:fld>
             <a:endParaRPr lang="ko-KR" altLang="en-US"/>
           </a:p>
@@ -1840,7 +1840,7 @@
           <a:p>
             <a:fld id="{D9F17D16-5A3B-479C-971A-D492ADD6ED98}" type="datetimeFigureOut">
               <a:rPr lang="ko-KR" altLang="en-US" smtClean="0"/>
-              <a:t>2026-03-07-Sat</a:t>
+              <a:t>2026-07-20-Mon</a:t>
             </a:fld>
             <a:endParaRPr lang="ko-KR" altLang="en-US"/>
           </a:p>
@@ -2252,7 +2252,7 @@
           <a:p>
             <a:fld id="{D9F17D16-5A3B-479C-971A-D492ADD6ED98}" type="datetimeFigureOut">
               <a:rPr lang="ko-KR" altLang="en-US" smtClean="0"/>
-              <a:t>2026-03-07-Sat</a:t>
+              <a:t>2026-07-20-Mon</a:t>
             </a:fld>
             <a:endParaRPr lang="ko-KR" altLang="en-US"/>
           </a:p>
@@ -2393,7 +2393,7 @@
           <a:p>
             <a:fld id="{D9F17D16-5A3B-479C-971A-D492ADD6ED98}" type="datetimeFigureOut">
               <a:rPr lang="ko-KR" altLang="en-US" smtClean="0"/>
-              <a:t>2026-03-07-Sat</a:t>
+              <a:t>2026-07-20-Mon</a:t>
             </a:fld>
             <a:endParaRPr lang="ko-KR" altLang="en-US"/>
           </a:p>
@@ -2506,7 +2506,7 @@
           <a:p>
             <a:fld id="{D9F17D16-5A3B-479C-971A-D492ADD6ED98}" type="datetimeFigureOut">
               <a:rPr lang="ko-KR" altLang="en-US" smtClean="0"/>
-              <a:t>2026-03-07-Sat</a:t>
+              <a:t>2026-07-20-Mon</a:t>
             </a:fld>
             <a:endParaRPr lang="ko-KR" altLang="en-US"/>
           </a:p>
@@ -2817,7 +2817,7 @@
           <a:p>
             <a:fld id="{D9F17D16-5A3B-479C-971A-D492ADD6ED98}" type="datetimeFigureOut">
               <a:rPr lang="ko-KR" altLang="en-US" smtClean="0"/>
-              <a:t>2026-03-07-Sat</a:t>
+              <a:t>2026-07-20-Mon</a:t>
             </a:fld>
             <a:endParaRPr lang="ko-KR" altLang="en-US"/>
           </a:p>
@@ -3105,7 +3105,7 @@
           <a:p>
             <a:fld id="{D9F17D16-5A3B-479C-971A-D492ADD6ED98}" type="datetimeFigureOut">
               <a:rPr lang="ko-KR" altLang="en-US" smtClean="0"/>
-              <a:t>2026-03-07-Sat</a:t>
+              <a:t>2026-07-20-Mon</a:t>
             </a:fld>
             <a:endParaRPr lang="ko-KR" altLang="en-US"/>
           </a:p>
@@ -3346,7 +3346,7 @@
           <a:p>
             <a:fld id="{D9F17D16-5A3B-479C-971A-D492ADD6ED98}" type="datetimeFigureOut">
               <a:rPr lang="ko-KR" altLang="en-US" smtClean="0"/>
-              <a:t>2026-03-07-Sat</a:t>
+              <a:t>2026-07-20-Mon</a:t>
             </a:fld>
             <a:endParaRPr lang="ko-KR" altLang="en-US"/>
           </a:p>
@@ -3769,106 +3769,127 @@
           <a:chExt cx="0" cy="0"/>
         </a:xfrm>
       </p:grpSpPr>
-      <p:sp>
-        <p:nvSpPr>
-          <p:cNvPr id="6" name="직사각형 5">
-            <a:extLst>
-              <a:ext uri="{FF2B5EF4-FFF2-40B4-BE49-F238E27FC236}">
-                <a16:creationId xmlns:a16="http://schemas.microsoft.com/office/drawing/2014/main" id="{AEC3A2B4-835B-C3C7-5139-09932F1E2AE2}"/>
-              </a:ext>
-            </a:extLst>
-          </p:cNvPr>
-          <p:cNvSpPr/>
+      <p:grpSp>
+        <p:nvGrpSpPr>
+          <p:cNvPr id="5" name="그룹 4">
+            <a:extLst>
+              <a:ext uri="{FF2B5EF4-FFF2-40B4-BE49-F238E27FC236}">
+                <a16:creationId xmlns:a16="http://schemas.microsoft.com/office/drawing/2014/main" id="{EC5D548F-609B-E9B8-C735-72D245240AFD}"/>
+              </a:ext>
+            </a:extLst>
+          </p:cNvPr>
+          <p:cNvGrpSpPr/>
           <p:nvPr/>
-        </p:nvSpPr>
-        <p:spPr>
+        </p:nvGrpSpPr>
+        <p:grpSpPr>
           <a:xfrm>
             <a:off x="2667000" y="0"/>
             <a:ext cx="6858000" cy="6858000"/>
+            <a:chOff x="2667000" y="0"/>
+            <a:chExt cx="6858000" cy="6858000"/>
           </a:xfrm>
-          <a:prstGeom prst="rect">
-            <a:avLst/>
-          </a:prstGeom>
-          <a:noFill/>
-          <a:ln>
+        </p:grpSpPr>
+        <p:sp>
+          <p:nvSpPr>
+            <p:cNvPr id="6" name="직사각형 5">
+              <a:extLst>
+                <a:ext uri="{FF2B5EF4-FFF2-40B4-BE49-F238E27FC236}">
+                  <a16:creationId xmlns:a16="http://schemas.microsoft.com/office/drawing/2014/main" id="{AEC3A2B4-835B-C3C7-5139-09932F1E2AE2}"/>
+                </a:ext>
+              </a:extLst>
+            </p:cNvPr>
+            <p:cNvSpPr/>
+            <p:nvPr/>
+          </p:nvSpPr>
+          <p:spPr>
+            <a:xfrm>
+              <a:off x="2667000" y="0"/>
+              <a:ext cx="6858000" cy="6858000"/>
+            </a:xfrm>
+            <a:prstGeom prst="rect">
+              <a:avLst/>
+            </a:prstGeom>
             <a:noFill/>
-          </a:ln>
-        </p:spPr>
-        <p:style>
-          <a:lnRef idx="2">
-            <a:schemeClr val="accent1">
-              <a:shade val="15000"/>
-            </a:schemeClr>
-          </a:lnRef>
-          <a:fillRef idx="1">
-            <a:schemeClr val="accent1"/>
-          </a:fillRef>
-          <a:effectRef idx="0">
-            <a:schemeClr val="accent1"/>
-          </a:effectRef>
-          <a:fontRef idx="minor">
-            <a:schemeClr val="lt1"/>
-          </a:fontRef>
-        </p:style>
-        <p:txBody>
-          <a:bodyPr rtlCol="0" anchor="ctr"/>
-          <a:lstStyle/>
-          <a:p>
-            <a:pPr algn="ctr"/>
-            <a:endParaRPr lang="ko-KR" altLang="en-US"/>
-          </a:p>
-        </p:txBody>
-      </p:sp>
-      <p:sp>
-        <p:nvSpPr>
-          <p:cNvPr id="2" name="직사각형 1">
-            <a:extLst>
-              <a:ext uri="{FF2B5EF4-FFF2-40B4-BE49-F238E27FC236}">
-                <a16:creationId xmlns:a16="http://schemas.microsoft.com/office/drawing/2014/main" id="{139E2BC1-BA58-3E59-02F5-66688191BF76}"/>
-              </a:ext>
-            </a:extLst>
-          </p:cNvPr>
-          <p:cNvSpPr/>
-          <p:nvPr/>
-        </p:nvSpPr>
-        <p:spPr>
-          <a:xfrm>
-            <a:off x="2667000" y="0"/>
-            <a:ext cx="6858000" cy="6858000"/>
-          </a:xfrm>
-          <a:prstGeom prst="rect">
-            <a:avLst/>
-          </a:prstGeom>
-          <a:noFill/>
-          <a:ln>
+            <a:ln>
+              <a:noFill/>
+            </a:ln>
+          </p:spPr>
+          <p:style>
+            <a:lnRef idx="2">
+              <a:schemeClr val="accent1">
+                <a:shade val="15000"/>
+              </a:schemeClr>
+            </a:lnRef>
+            <a:fillRef idx="1">
+              <a:schemeClr val="accent1"/>
+            </a:fillRef>
+            <a:effectRef idx="0">
+              <a:schemeClr val="accent1"/>
+            </a:effectRef>
+            <a:fontRef idx="minor">
+              <a:schemeClr val="lt1"/>
+            </a:fontRef>
+          </p:style>
+          <p:txBody>
+            <a:bodyPr rtlCol="0" anchor="ctr"/>
+            <a:lstStyle/>
+            <a:p>
+              <a:pPr algn="ctr"/>
+              <a:endParaRPr lang="ko-KR" altLang="en-US"/>
+            </a:p>
+          </p:txBody>
+        </p:sp>
+        <p:sp>
+          <p:nvSpPr>
+            <p:cNvPr id="2" name="직사각형 1">
+              <a:extLst>
+                <a:ext uri="{FF2B5EF4-FFF2-40B4-BE49-F238E27FC236}">
+                  <a16:creationId xmlns:a16="http://schemas.microsoft.com/office/drawing/2014/main" id="{139E2BC1-BA58-3E59-02F5-66688191BF76}"/>
+                </a:ext>
+              </a:extLst>
+            </p:cNvPr>
+            <p:cNvSpPr/>
+            <p:nvPr/>
+          </p:nvSpPr>
+          <p:spPr>
+            <a:xfrm>
+              <a:off x="2667000" y="0"/>
+              <a:ext cx="6858000" cy="6858000"/>
+            </a:xfrm>
+            <a:prstGeom prst="rect">
+              <a:avLst/>
+            </a:prstGeom>
             <a:noFill/>
-          </a:ln>
-        </p:spPr>
-        <p:style>
-          <a:lnRef idx="2">
-            <a:schemeClr val="accent1">
-              <a:shade val="15000"/>
-            </a:schemeClr>
-          </a:lnRef>
-          <a:fillRef idx="1">
-            <a:schemeClr val="accent1"/>
-          </a:fillRef>
-          <a:effectRef idx="0">
-            <a:schemeClr val="accent1"/>
-          </a:effectRef>
-          <a:fontRef idx="minor">
-            <a:schemeClr val="lt1"/>
-          </a:fontRef>
-        </p:style>
-        <p:txBody>
-          <a:bodyPr rtlCol="0" anchor="ctr"/>
-          <a:lstStyle/>
-          <a:p>
-            <a:pPr algn="ctr"/>
-            <a:endParaRPr lang="ko-KR" altLang="en-US"/>
-          </a:p>
-        </p:txBody>
-      </p:sp>
+            <a:ln>
+              <a:noFill/>
+            </a:ln>
+          </p:spPr>
+          <p:style>
+            <a:lnRef idx="2">
+              <a:schemeClr val="accent1">
+                <a:shade val="15000"/>
+              </a:schemeClr>
+            </a:lnRef>
+            <a:fillRef idx="1">
+              <a:schemeClr val="accent1"/>
+            </a:fillRef>
+            <a:effectRef idx="0">
+              <a:schemeClr val="accent1"/>
+            </a:effectRef>
+            <a:fontRef idx="minor">
+              <a:schemeClr val="lt1"/>
+            </a:fontRef>
+          </p:style>
+          <p:txBody>
+            <a:bodyPr rtlCol="0" anchor="ctr"/>
+            <a:lstStyle/>
+            <a:p>
+              <a:pPr algn="ctr"/>
+              <a:endParaRPr lang="ko-KR" altLang="en-US"/>
+            </a:p>
+          </p:txBody>
+        </p:sp>
+      </p:grpSp>
     </p:spTree>
     <p:extLst>
       <p:ext uri="{BB962C8B-B14F-4D97-AF65-F5344CB8AC3E}">
@@ -3915,10 +3936,10 @@
       </p:grpSpPr>
       <p:pic>
         <p:nvPicPr>
-          <p:cNvPr id="3" name="그림 2">
-            <a:extLst>
-              <a:ext uri="{FF2B5EF4-FFF2-40B4-BE49-F238E27FC236}">
-                <a16:creationId xmlns:a16="http://schemas.microsoft.com/office/drawing/2014/main" id="{8F0D4C86-1FC2-ACE4-F1E4-4FCFA09CC677}"/>
+          <p:cNvPr id="17" name="그림 16">
+            <a:extLst>
+              <a:ext uri="{FF2B5EF4-FFF2-40B4-BE49-F238E27FC236}">
+                <a16:creationId xmlns:a16="http://schemas.microsoft.com/office/drawing/2014/main" id="{F003D8D4-3171-9929-8031-066EAB7B4FAB}"/>
               </a:ext>
             </a:extLst>
           </p:cNvPr>
@@ -3929,78 +3950,6 @@
         </p:nvPicPr>
         <p:blipFill>
           <a:blip r:embed="rId2">
-            <a:extLst>
-              <a:ext uri="{28A0092B-C50C-407E-A947-70E740481C1C}">
-                <a14:useLocalDpi xmlns:a14="http://schemas.microsoft.com/office/drawing/2010/main" val="0"/>
-              </a:ext>
-            </a:extLst>
-          </a:blip>
-          <a:stretch>
-            <a:fillRect/>
-          </a:stretch>
-        </p:blipFill>
-        <p:spPr>
-          <a:xfrm>
-            <a:off x="5320589" y="2018540"/>
-            <a:ext cx="668032" cy="426642"/>
-          </a:xfrm>
-          <a:prstGeom prst="rect">
-            <a:avLst/>
-          </a:prstGeom>
-        </p:spPr>
-      </p:pic>
-      <p:pic>
-        <p:nvPicPr>
-          <p:cNvPr id="4" name="그림 3">
-            <a:extLst>
-              <a:ext uri="{FF2B5EF4-FFF2-40B4-BE49-F238E27FC236}">
-                <a16:creationId xmlns:a16="http://schemas.microsoft.com/office/drawing/2014/main" id="{26534AD8-71C2-2199-191B-08368311AF40}"/>
-              </a:ext>
-            </a:extLst>
-          </p:cNvPr>
-          <p:cNvPicPr>
-            <a:picLocks noChangeAspect="1"/>
-          </p:cNvPicPr>
-          <p:nvPr/>
-        </p:nvPicPr>
-        <p:blipFill>
-          <a:blip r:embed="rId2">
-            <a:extLst>
-              <a:ext uri="{28A0092B-C50C-407E-A947-70E740481C1C}">
-                <a14:useLocalDpi xmlns:a14="http://schemas.microsoft.com/office/drawing/2010/main" val="0"/>
-              </a:ext>
-            </a:extLst>
-          </a:blip>
-          <a:stretch>
-            <a:fillRect/>
-          </a:stretch>
-        </p:blipFill>
-        <p:spPr>
-          <a:xfrm flipH="1">
-            <a:off x="6203379" y="2018540"/>
-            <a:ext cx="668032" cy="426642"/>
-          </a:xfrm>
-          <a:prstGeom prst="rect">
-            <a:avLst/>
-          </a:prstGeom>
-        </p:spPr>
-      </p:pic>
-      <p:pic>
-        <p:nvPicPr>
-          <p:cNvPr id="17" name="그림 16">
-            <a:extLst>
-              <a:ext uri="{FF2B5EF4-FFF2-40B4-BE49-F238E27FC236}">
-                <a16:creationId xmlns:a16="http://schemas.microsoft.com/office/drawing/2014/main" id="{F003D8D4-3171-9929-8031-066EAB7B4FAB}"/>
-              </a:ext>
-            </a:extLst>
-          </p:cNvPr>
-          <p:cNvPicPr>
-            <a:picLocks noChangeAspect="1"/>
-          </p:cNvPicPr>
-          <p:nvPr/>
-        </p:nvPicPr>
-        <p:blipFill>
-          <a:blip r:embed="rId3">
             <a:extLst>
               <a:ext uri="{28A0092B-C50C-407E-A947-70E740481C1C}">
                 <a14:useLocalDpi xmlns:a14="http://schemas.microsoft.com/office/drawing/2010/main" val="0"/>
@@ -4023,10 +3972,10 @@
       </p:pic>
       <p:pic>
         <p:nvPicPr>
-          <p:cNvPr id="7" name="그림 6">
-            <a:extLst>
-              <a:ext uri="{FF2B5EF4-FFF2-40B4-BE49-F238E27FC236}">
-                <a16:creationId xmlns:a16="http://schemas.microsoft.com/office/drawing/2014/main" id="{4502A1CE-3C05-C513-9ACA-C6D71881E7DA}"/>
+          <p:cNvPr id="3" name="그림 2">
+            <a:extLst>
+              <a:ext uri="{FF2B5EF4-FFF2-40B4-BE49-F238E27FC236}">
+                <a16:creationId xmlns:a16="http://schemas.microsoft.com/office/drawing/2014/main" id="{F00B1C0C-5391-28E6-0DDF-2351AB10B3C8}"/>
               </a:ext>
             </a:extLst>
           </p:cNvPr>
@@ -4036,22 +3985,22 @@
           <p:nvPr/>
         </p:nvPicPr>
         <p:blipFill>
-          <a:blip r:embed="rId4">
+          <a:blip r:embed="rId3">
             <a:extLst>
               <a:ext uri="{28A0092B-C50C-407E-A947-70E740481C1C}">
                 <a14:useLocalDpi xmlns:a14="http://schemas.microsoft.com/office/drawing/2010/main" val="0"/>
               </a:ext>
             </a:extLst>
           </a:blip>
-          <a:srcRect l="46989" t="37139" r="46989" b="60001"/>
+          <a:srcRect l="8018" t="13951" r="4458" b="45371"/>
           <a:stretch>
             <a:fillRect/>
           </a:stretch>
         </p:blipFill>
         <p:spPr>
           <a:xfrm>
-            <a:off x="5889523" y="2506142"/>
-            <a:ext cx="412954" cy="196215"/>
+            <a:off x="5376167" y="2069636"/>
+            <a:ext cx="1439665" cy="344380"/>
           </a:xfrm>
           <a:prstGeom prst="rect">
             <a:avLst/>
@@ -4060,10 +4009,10 @@
       </p:pic>
       <p:pic>
         <p:nvPicPr>
-          <p:cNvPr id="10" name="그림 9">
-            <a:extLst>
-              <a:ext uri="{FF2B5EF4-FFF2-40B4-BE49-F238E27FC236}">
-                <a16:creationId xmlns:a16="http://schemas.microsoft.com/office/drawing/2014/main" id="{FD137B33-93D2-43F7-9800-66A15521F4CB}"/>
+          <p:cNvPr id="11" name="그림 10">
+            <a:extLst>
+              <a:ext uri="{FF2B5EF4-FFF2-40B4-BE49-F238E27FC236}">
+                <a16:creationId xmlns:a16="http://schemas.microsoft.com/office/drawing/2014/main" id="{DDF8E604-CAE2-EDBF-11E1-22BF67601A5D}"/>
               </a:ext>
             </a:extLst>
           </p:cNvPr>
@@ -4073,22 +4022,22 @@
           <p:nvPr/>
         </p:nvPicPr>
         <p:blipFill>
-          <a:blip r:embed="rId5">
+          <a:blip r:embed="rId4">
             <a:extLst>
               <a:ext uri="{28A0092B-C50C-407E-A947-70E740481C1C}">
                 <a14:useLocalDpi xmlns:a14="http://schemas.microsoft.com/office/drawing/2010/main" val="0"/>
               </a:ext>
             </a:extLst>
           </a:blip>
-          <a:srcRect l="38693" t="29434" r="38693" b="64345"/>
+          <a:srcRect l="45644" t="35200" r="45644" b="58223"/>
           <a:stretch>
             <a:fillRect/>
           </a:stretch>
         </p:blipFill>
         <p:spPr>
           <a:xfrm>
-            <a:off x="5320589" y="2018540"/>
-            <a:ext cx="1550822" cy="426642"/>
+            <a:off x="5797296" y="2414016"/>
+            <a:ext cx="597408" cy="451104"/>
           </a:xfrm>
           <a:prstGeom prst="rect">
             <a:avLst/>

</xml_diff>